<commit_message>
Bible quotes on the site as printed (his OK, 25 Oct): 16 pages and decks
21 word fixes, 44 letter fixes and 2 slips of his CUV file (Rom 7:18,
Rev 16:11); each quote now matches the checked text (CUV / eBible ASV, KJV).

Co-Authored-By: Claude Opus 5.5 <noreply@anthropic.com>
</commit_message>
<xml_diff>
--- a/preaching/提摩太前書三章15-16節_神的家與敬虔的奧秘.pptx
+++ b/preaching/提摩太前書三章15-16節_神的家與敬虔的奧秘.pptx
@@ -9798,7 +9798,7 @@
                 <a:ea typeface="Calibri" pitchFamily="34" charset="-122"/>
                 <a:cs typeface="Calibri" pitchFamily="34" charset="-120"/>
               </a:rPr>
-              <a:t>倘若我耽延，你也可以知道在　神的家中當怎樣行；這家就是永生　神的教會，真理的柱石和根基。</a:t>
+              <a:t>倘若我耽延日久，你也可以知道在　神的家中當怎樣行；這家就是永生　神的教會，真理的柱石和根基。</a:t>
             </a:r>
             <a:endParaRPr lang="en-US" sz="2200" dirty="0"/>
           </a:p>
@@ -10363,7 +10363,7 @@
                 <a:ea typeface="Calibri" pitchFamily="34" charset="-122"/>
                 <a:cs typeface="Calibri" pitchFamily="34" charset="-120"/>
               </a:rPr>
-              <a:t>⑤ 被世人信服——從11個門徒到全球信仰。45%的流失不是福音失效，是宣揚不足（徒4:20：「我們所見所聽的，不能不說」）。</a:t>
+              <a:t>⑤ 被世人信服——從11個門徒到全球信仰。45%的流失不是福音失效，是宣揚不足（徒4:20：「我們所看見所聽見的，不能不說」）。</a:t>
             </a:r>
             <a:endParaRPr lang="en-US" sz="1900" dirty="0"/>
           </a:p>
@@ -14489,7 +14489,7 @@
                 <a:ea typeface="Calibri" pitchFamily="34" charset="-122"/>
                 <a:cs typeface="Calibri" pitchFamily="34" charset="-120"/>
               </a:rPr>
-              <a:t>84:11 耶和華神是日頭，是盾牌；他要賜下恩惠和榮耀。  The LORD God is a sun and shield; he bestows favor and honor.</a:t>
+              <a:t>84:11 耶和華神是日頭，是盾牌，要賜下恩惠和榮耀。  The LORD God is a sun and shield; he bestows favor and honor.</a:t>
             </a:r>
             <a:endParaRPr lang="en-US" sz="1250" dirty="0"/>
           </a:p>
@@ -15687,7 +15687,7 @@
                 <a:ea typeface="Calibri" pitchFamily="34" charset="-122"/>
                 <a:cs typeface="Calibri" pitchFamily="34" charset="-120"/>
               </a:rPr>
-              <a:t>大哉，敬虔的奧秘，無人不以為然！就是　神在肉身顯現，被聖靈稱義，被天使看見，被傳於外邦，被世人信服，被接在榮耀裡。</a:t>
+              <a:t>大哉，敬虔的奧祕，無人不以為然！就是　神在肉身顯現，被聖靈稱義，被天使看見，被傳於外邦，被世人信服，被接在榮耀裏。</a:t>
             </a:r>
             <a:endParaRPr lang="en-US" sz="2100" dirty="0"/>
           </a:p>
@@ -17298,7 +17298,7 @@
                 <a:ea typeface="Calibri" pitchFamily="34" charset="-122"/>
                 <a:cs typeface="Calibri" pitchFamily="34" charset="-120"/>
               </a:rPr>
-              <a:t>「在神的家中當怎樣行？」</a:t>
+              <a:t>「在神的家中當怎樣行。」</a:t>
             </a:r>
             <a:endParaRPr lang="en-US" sz="1900" dirty="0"/>
           </a:p>

</xml_diff>